<commit_message>
Revise the midterm poster so the introduction, UI, and threading are readable.
Explain anonymous dynamic networks, counting, and history trees in plain language, add the student-mode glossary screenshot, and state both the worker-thread attempt and the frame-split public demo.

Co-authored-by: Kazane1225 <kajya.h1225@gmail.com>
</commit_message>
<xml_diff>
--- a/poster/STSA_midterm_poster.pptx
+++ b/poster/STSA_midterm_poster.pptx
@@ -256,7 +256,7 @@
             </c:numRef>
           </c:val>
         </c:ser>
-        <c:gapWidth val="80"/>
+        <c:gapWidth val="70"/>
         <c:axId val="-2068027336"/>
         <c:axId val="-2113994440"/>
       </c:barChart>
@@ -275,7 +275,7 @@
           <a:lstStyle/>
           <a:p>
             <a:pPr>
-              <a:defRPr sz="1100">
+              <a:defRPr sz="1000">
                 <a:latin typeface="Arial"/>
               </a:defRPr>
             </a:pPr>
@@ -302,7 +302,7 @@
           <a:lstStyle/>
           <a:p>
             <a:pPr>
-              <a:defRPr sz="1000">
+              <a:defRPr sz="900">
                 <a:latin typeface="Arial"/>
               </a:defRPr>
             </a:pPr>
@@ -319,7 +319,7 @@
         <a:lstStyle/>
         <a:p>
           <a:pPr>
-            <a:defRPr sz="1100">
+            <a:defRPr sz="1000">
               <a:latin typeface="Arial"/>
             </a:defRPr>
           </a:pPr>
@@ -3656,7 +3656,7 @@
         <p:spPr>
           <a:xfrm>
             <a:off x="4773168" y="1499616"/>
-            <a:ext cx="0" cy="8814816"/>
+            <a:ext cx="0" cy="9308592"/>
           </a:xfrm>
           <a:prstGeom prst="line">
             <a:avLst/>
@@ -3773,7 +3773,7 @@
         <p:spPr>
           <a:xfrm>
             <a:off x="219456" y="1837943"/>
-            <a:ext cx="4370832" cy="1642872"/>
+            <a:ext cx="4370832" cy="2845308"/>
           </a:xfrm>
           <a:prstGeom prst="rect">
             <a:avLst/>
@@ -3794,11 +3794,11 @@
                 <a:spcPts val="0"/>
               </a:spcBef>
               <a:spcAft>
-                <a:spcPts val="100"/>
+                <a:spcPts val="300"/>
               </a:spcAft>
             </a:pPr>
             <a:r>
-              <a:rPr sz="1500" b="0" i="0">
+              <a:rPr sz="1300" b="0" i="0">
                 <a:solidFill>
                   <a:srgbClr val="222222"/>
                 </a:solidFill>
@@ -3806,7 +3806,7 @@
                 <a:ea typeface="Arial"/>
                 <a:cs typeface="Arial"/>
               </a:rPr>
-              <a:t>•  No IDs. Every agent runs the same program.</a:t>
+              <a:t>Agents have no names, and every agent runs the same program. Each round, links may appear or disappear. An agent hears a broadcast only from its current neighbors.</a:t>
             </a:r>
           </a:p>
           <a:p>
@@ -3818,11 +3818,11 @@
                 <a:spcPts val="0"/>
               </a:spcBef>
               <a:spcAft>
-                <a:spcPts val="100"/>
+                <a:spcPts val="300"/>
               </a:spcAft>
             </a:pPr>
             <a:r>
-              <a:rPr sz="1500" b="0" i="0">
+              <a:rPr sz="1300" b="0" i="0">
                 <a:solidFill>
                   <a:srgbClr val="222222"/>
                 </a:solidFill>
@@ -3830,7 +3830,7 @@
                 <a:ea typeface="Arial"/>
                 <a:cs typeface="Arial"/>
               </a:rPr>
-              <a:t>•  Broadcast only. Links can change each round.</a:t>
+              <a:t>If two agents have seen the same messages, they cannot be told apart. They cannot count by pointing at neighbors. The task is to infer n, the number of agents [1].</a:t>
             </a:r>
           </a:p>
           <a:p>
@@ -3842,11 +3842,11 @@
                 <a:spcPts val="0"/>
               </a:spcBef>
               <a:spcAft>
-                <a:spcPts val="100"/>
+                <a:spcPts val="300"/>
               </a:spcAft>
             </a:pPr>
             <a:r>
-              <a:rPr sz="1500" b="0" i="0">
+              <a:rPr sz="1300" b="0" i="0">
                 <a:solidFill>
                   <a:srgbClr val="222222"/>
                 </a:solidFill>
@@ -3854,7 +3854,7 @@
                 <a:ea typeface="Arial"/>
                 <a:cs typeface="Arial"/>
               </a:rPr>
-              <a:t>•  History tree: one node per group at round t.</a:t>
+              <a:t>A history tree stores that view. One level is one round. Same-looking agents share a node. A black edge is a split. A red edge is a message. Anonymity 1 means one agent.</a:t>
             </a:r>
           </a:p>
           <a:p>
@@ -3866,11 +3866,11 @@
                 <a:spcPts val="0"/>
               </a:spcBef>
               <a:spcAft>
-                <a:spcPts val="100"/>
+                <a:spcPts val="300"/>
               </a:spcAft>
             </a:pPr>
             <a:r>
-              <a:rPr sz="1500" b="0" i="0">
+              <a:rPr sz="1300" b="0" i="0">
                 <a:solidFill>
                   <a:srgbClr val="222222"/>
                 </a:solidFill>
@@ -3878,7 +3878,7 @@
                 <a:ea typeface="Arial"/>
                 <a:cs typeface="Arial"/>
               </a:rPr>
-              <a:t>•  a(v) is how many agents share that node.</a:t>
+              <a:t>With one leader, stabilizing settles on the correct n by round 2n−2, and may guess wrong first. Terminating stops only after n is proved, by round 3n−2 [1].</a:t>
             </a:r>
           </a:p>
           <a:p>
@@ -3894,7 +3894,7 @@
               </a:spcAft>
             </a:pPr>
             <a:r>
-              <a:rPr sz="1500" b="0" i="0">
+              <a:rPr sz="1300" b="0" i="0">
                 <a:solidFill>
                   <a:srgbClr val="222222"/>
                 </a:solidFill>
@@ -3902,257 +3902,20 @@
                 <a:ea typeface="Arial"/>
                 <a:cs typeface="Arial"/>
               </a:rPr>
-              <a:t>•  One leader: n settles by 2n−2 [1], [2].</a:t>
-            </a:r>
-          </a:p>
-          <a:p>
-            <a:pPr algn="l">
-              <a:lnSpc>
-                <a:spcPct val="112000"/>
-              </a:lnSpc>
-              <a:spcBef>
-                <a:spcPts val="0"/>
-              </a:spcBef>
-              <a:spcAft>
-                <a:spcPts val="100"/>
-              </a:spcAft>
-            </a:pPr>
-            <a:r>
-              <a:rPr sz="1500" b="0" i="0">
-                <a:solidFill>
-                  <a:srgbClr val="222222"/>
-                </a:solidFill>
-                <a:latin typeface="Arial"/>
-                <a:ea typeface="Arial"/>
-                <a:cs typeface="Arial"/>
-              </a:rPr>
-              <a:t>•  A proof of n takes until round 3n−2 [1].</a:t>
-            </a:r>
-          </a:p>
-          <a:p>
-            <a:pPr algn="l">
-              <a:lnSpc>
-                <a:spcPct val="112000"/>
-              </a:lnSpc>
-              <a:spcBef>
-                <a:spcPts val="0"/>
-              </a:spcBef>
-              <a:spcAft>
-                <a:spcPts val="0"/>
-              </a:spcAft>
-            </a:pPr>
-            <a:r>
-              <a:rPr sz="1500" b="0" i="0">
-                <a:solidFill>
-                  <a:srgbClr val="222222"/>
-                </a:solidFill>
-                <a:latin typeface="Arial"/>
-                <a:ea typeface="Arial"/>
-                <a:cs typeface="Arial"/>
-              </a:rPr>
-              <a:t>•  This work draws that tree and stays fast.</a:t>
-            </a:r>
-          </a:p>
-        </p:txBody>
-      </p:sp>
-      <p:sp>
-        <p:nvSpPr>
-          <p:cNvPr id="12" name="Rectangle 11"/>
-          <p:cNvSpPr/>
+              <a:t>Prof. Viglietta uses this simulator in class. Students use the same page. Fig. 2 is its glossary.</a:t>
+            </a:r>
+          </a:p>
+        </p:txBody>
+      </p:sp>
+      <p:sp>
+        <p:nvSpPr>
+          <p:cNvPr id="12" name="TextBox 11"/>
+          <p:cNvSpPr txBox="1"/>
           <p:nvPr/>
         </p:nvSpPr>
         <p:spPr>
           <a:xfrm>
-            <a:off x="219456" y="3553968"/>
-            <a:ext cx="4370832" cy="1258316"/>
-          </a:xfrm>
-          <a:prstGeom prst="rect">
-            <a:avLst/>
-          </a:prstGeom>
-          <a:solidFill>
-            <a:srgbClr val="E7EEF7"/>
-          </a:solidFill>
-          <a:ln w="12700">
-            <a:solidFill>
-              <a:srgbClr val="395E89"/>
-            </a:solidFill>
-          </a:ln>
-          <a:effectLst/>
-        </p:spPr>
-        <p:style>
-          <a:lnRef idx="1">
-            <a:schemeClr val="accent1"/>
-          </a:lnRef>
-          <a:fillRef idx="3">
-            <a:schemeClr val="accent1"/>
-          </a:fillRef>
-          <a:effectRef idx="2">
-            <a:schemeClr val="accent1"/>
-          </a:effectRef>
-          <a:fontRef idx="minor">
-            <a:schemeClr val="lt1"/>
-          </a:fontRef>
-        </p:style>
-        <p:txBody>
-          <a:bodyPr rtlCol="0" anchor="ctr"/>
-          <a:lstStyle/>
-          <a:p>
-            <a:pPr algn="ctr"/>
-          </a:p>
-        </p:txBody>
-      </p:sp>
-      <p:sp>
-        <p:nvSpPr>
-          <p:cNvPr id="13" name="TextBox 12"/>
-          <p:cNvSpPr txBox="1"/>
-          <p:nvPr/>
-        </p:nvSpPr>
-        <p:spPr>
-          <a:xfrm>
-            <a:off x="274320" y="3572256"/>
-            <a:ext cx="4261104" cy="1221740"/>
-          </a:xfrm>
-          <a:prstGeom prst="rect">
-            <a:avLst/>
-          </a:prstGeom>
-          <a:noFill/>
-        </p:spPr>
-        <p:txBody>
-          <a:bodyPr wrap="square" lIns="27432" rIns="27432" tIns="27432" bIns="18288" anchor="t">
-            <a:noAutofit/>
-          </a:bodyPr>
-          <a:lstStyle/>
-          <a:p>
-            <a:pPr algn="l">
-              <a:lnSpc>
-                <a:spcPct val="112000"/>
-              </a:lnSpc>
-              <a:spcBef>
-                <a:spcPts val="0"/>
-              </a:spcBef>
-              <a:spcAft>
-                <a:spcPts val="200"/>
-              </a:spcAft>
-            </a:pPr>
-            <a:r>
-              <a:rPr sz="1500" b="1" i="0">
-                <a:solidFill>
-                  <a:srgbClr val="1F497D"/>
-                </a:solidFill>
-                <a:latin typeface="Arial"/>
-                <a:ea typeface="Arial"/>
-                <a:cs typeface="Arial"/>
-              </a:rPr>
-              <a:t>Reading a history tree</a:t>
-            </a:r>
-          </a:p>
-          <a:p>
-            <a:pPr algn="l">
-              <a:lnSpc>
-                <a:spcPct val="112000"/>
-              </a:lnSpc>
-              <a:spcBef>
-                <a:spcPts val="0"/>
-              </a:spcBef>
-              <a:spcAft>
-                <a:spcPts val="100"/>
-              </a:spcAft>
-            </a:pPr>
-            <a:r>
-              <a:rPr sz="1500" b="0" i="0">
-                <a:solidFill>
-                  <a:srgbClr val="222222"/>
-                </a:solidFill>
-                <a:latin typeface="Arial"/>
-                <a:ea typeface="Arial"/>
-                <a:cs typeface="Arial"/>
-              </a:rPr>
-              <a:t>•  Black edge — a class splits.</a:t>
-            </a:r>
-          </a:p>
-          <a:p>
-            <a:pPr algn="l">
-              <a:lnSpc>
-                <a:spcPct val="112000"/>
-              </a:lnSpc>
-              <a:spcBef>
-                <a:spcPts val="0"/>
-              </a:spcBef>
-              <a:spcAft>
-                <a:spcPts val="100"/>
-              </a:spcAft>
-            </a:pPr>
-            <a:r>
-              <a:rPr sz="1500" b="0" i="0">
-                <a:solidFill>
-                  <a:srgbClr val="222222"/>
-                </a:solidFill>
-                <a:latin typeface="Arial"/>
-                <a:ea typeface="Arial"/>
-                <a:cs typeface="Arial"/>
-              </a:rPr>
-              <a:t>•  Red edge — messages of that round.</a:t>
-            </a:r>
-          </a:p>
-          <a:p>
-            <a:pPr algn="l">
-              <a:lnSpc>
-                <a:spcPct val="112000"/>
-              </a:lnSpc>
-              <a:spcBef>
-                <a:spcPts val="0"/>
-              </a:spcBef>
-              <a:spcAft>
-                <a:spcPts val="100"/>
-              </a:spcAft>
-            </a:pPr>
-            <a:r>
-              <a:rPr sz="1500" b="0" i="0">
-                <a:solidFill>
-                  <a:srgbClr val="222222"/>
-                </a:solidFill>
-                <a:latin typeface="Arial"/>
-                <a:ea typeface="Arial"/>
-                <a:cs typeface="Arial"/>
-              </a:rPr>
-              <a:t>•  Vista — the part one agent can build.</a:t>
-            </a:r>
-          </a:p>
-          <a:p>
-            <a:pPr algn="l">
-              <a:lnSpc>
-                <a:spcPct val="112000"/>
-              </a:lnSpc>
-              <a:spcBef>
-                <a:spcPts val="0"/>
-              </a:spcBef>
-              <a:spcAft>
-                <a:spcPts val="0"/>
-              </a:spcAft>
-            </a:pPr>
-            <a:r>
-              <a:rPr sz="1500" b="0" i="0">
-                <a:solidFill>
-                  <a:srgbClr val="222222"/>
-                </a:solidFill>
-                <a:latin typeface="Arial"/>
-                <a:ea typeface="Arial"/>
-                <a:cs typeface="Arial"/>
-              </a:rPr>
-              <a:t>•  Anonymity 1 — the agent is unique.</a:t>
-            </a:r>
-          </a:p>
-        </p:txBody>
-      </p:sp>
-      <p:sp>
-        <p:nvSpPr>
-          <p:cNvPr id="14" name="TextBox 13"/>
-          <p:cNvSpPr txBox="1"/>
-          <p:nvPr/>
-        </p:nvSpPr>
-        <p:spPr>
-          <a:xfrm>
-            <a:off x="219456" y="4903724"/>
+            <a:off x="219456" y="4710684"/>
             <a:ext cx="4370832" cy="292608"/>
           </a:xfrm>
           <a:prstGeom prst="rect">
@@ -4193,13 +3956,13 @@
       </p:sp>
       <p:cxnSp>
         <p:nvCxnSpPr>
-          <p:cNvPr id="15" name="Connector 14"/>
+          <p:cNvPr id="13" name="Connector 12"/>
           <p:cNvCxnSpPr/>
           <p:nvPr/>
         </p:nvCxnSpPr>
         <p:spPr>
           <a:xfrm>
-            <a:off x="219456" y="5196332"/>
+            <a:off x="219456" y="5003292"/>
             <a:ext cx="4370832" cy="0"/>
           </a:xfrm>
           <a:prstGeom prst="line">
@@ -4228,14 +3991,14 @@
       </p:cxnSp>
       <p:sp>
         <p:nvSpPr>
-          <p:cNvPr id="16" name="TextBox 15"/>
+          <p:cNvPr id="14" name="TextBox 13"/>
           <p:cNvSpPr txBox="1"/>
           <p:nvPr/>
         </p:nvSpPr>
         <p:spPr>
           <a:xfrm>
-            <a:off x="219456" y="5242052"/>
-            <a:ext cx="4370832" cy="3296920"/>
+            <a:off x="219456" y="5049012"/>
+            <a:ext cx="4370832" cy="2497328"/>
           </a:xfrm>
           <a:prstGeom prst="rect">
             <a:avLst/>
@@ -4256,11 +4019,11 @@
                 <a:spcPts val="0"/>
               </a:spcBef>
               <a:spcAft>
-                <a:spcPts val="200"/>
+                <a:spcPts val="100"/>
               </a:spcAft>
             </a:pPr>
             <a:r>
-              <a:rPr sz="1500" b="1" i="0">
+              <a:rPr sz="1500" b="0" i="0">
                 <a:solidFill>
                   <a:srgbClr val="1F497D"/>
                 </a:solidFill>
@@ -4268,7 +4031,7 @@
                 <a:ea typeface="Arial"/>
                 <a:cs typeface="Arial"/>
               </a:rPr>
-              <a:t>2.1 Model — same setting as [1].</a:t>
+              <a:t>2.1 Model. One leader, input 0, no port labels [1].</a:t>
             </a:r>
           </a:p>
           <a:p>
@@ -4280,19 +4043,19 @@
                 <a:spcPts val="0"/>
               </a:spcBef>
               <a:spcAft>
-                <a:spcPts val="100"/>
+                <a:spcPts val="0"/>
               </a:spcAft>
             </a:pPr>
             <a:r>
               <a:rPr sz="1500" b="0" i="0">
                 <a:solidFill>
-                  <a:srgbClr val="222222"/>
+                  <a:srgbClr val="1F497D"/>
                 </a:solidFill>
                 <a:latin typeface="Arial"/>
                 <a:ea typeface="Arial"/>
                 <a:cs typeface="Arial"/>
               </a:rPr>
-              <a:t>•  Undirected dynamic graph, one leader.</a:t>
+              <a:t>2.2 C to WebAssembly. Left: network. Right: tree.</a:t>
             </a:r>
           </a:p>
           <a:p>
@@ -4304,19 +4067,19 @@
                 <a:spcPts val="0"/>
               </a:spcBef>
               <a:spcAft>
-                <a:spcPts val="400"/>
+                <a:spcPts val="200"/>
               </a:spcAft>
             </a:pPr>
             <a:r>
-              <a:rPr sz="1500" b="0" i="0">
-                <a:solidFill>
-                  <a:srgbClr val="222222"/>
+              <a:rPr sz="1200" b="1" i="0">
+                <a:solidFill>
+                  <a:srgbClr val="1F497D"/>
                 </a:solidFill>
                 <a:latin typeface="Arial"/>
                 <a:ea typeface="Arial"/>
                 <a:cs typeface="Arial"/>
               </a:rPr>
-              <a:t>•  Leader input is 0. No port labels.</a:t>
+              <a:t>https://kazane1225.github.io/Research_NetworkSimulater/</a:t>
             </a:r>
           </a:p>
           <a:p>
@@ -4340,7 +4103,7 @@
                 <a:ea typeface="Arial"/>
                 <a:cs typeface="Arial"/>
               </a:rPr>
-              <a:t>2.2 Program.</a:t>
+              <a:t>2.3 Append of the last round: O(R n²) → O(n²).</a:t>
             </a:r>
           </a:p>
           <a:p>
@@ -4352,19 +4115,19 @@
                 <a:spcPts val="0"/>
               </a:spcBef>
               <a:spcAft>
-                <a:spcPts val="100"/>
+                <a:spcPts val="0"/>
               </a:spcAft>
             </a:pPr>
             <a:r>
-              <a:rPr sz="1500" b="0" i="0">
-                <a:solidFill>
-                  <a:srgbClr val="222222"/>
+              <a:rPr sz="1500" b="1" i="0">
+                <a:solidFill>
+                  <a:srgbClr val="1F497D"/>
                 </a:solidFill>
                 <a:latin typeface="Arial"/>
                 <a:ea typeface="Arial"/>
                 <a:cs typeface="Arial"/>
               </a:rPr>
-              <a:t>•  C code, compiled to WebAssembly.</a:t>
+              <a:t>2.4 Professor mode is the class default.</a:t>
             </a:r>
           </a:p>
           <a:p>
@@ -4376,7 +4139,7 @@
                 <a:spcPts val="0"/>
               </a:spcBef>
               <a:spcAft>
-                <a:spcPts val="200"/>
+                <a:spcPts val="0"/>
               </a:spcAft>
             </a:pPr>
             <a:r>
@@ -4388,7 +4151,7 @@
                 <a:ea typeface="Arial"/>
                 <a:cs typeface="Arial"/>
               </a:rPr>
-              <a:t>•  Left: network. Right: colored tree.</a:t>
+              <a:t>Student mode: Glossary, Tour, Learn, Help.</a:t>
             </a:r>
           </a:p>
           <a:p>
@@ -4400,19 +4163,19 @@
                 <a:spcPts val="0"/>
               </a:spcBef>
               <a:spcAft>
-                <a:spcPts val="400"/>
+                <a:spcPts val="200"/>
               </a:spcAft>
             </a:pPr>
             <a:r>
-              <a:rPr sz="1200" b="1" i="0">
-                <a:solidFill>
-                  <a:srgbClr val="1F497D"/>
+              <a:rPr sz="1500" b="0" i="0">
+                <a:solidFill>
+                  <a:srgbClr val="222222"/>
                 </a:solidFill>
                 <a:latin typeface="Arial"/>
                 <a:ea typeface="Arial"/>
                 <a:cs typeface="Arial"/>
               </a:rPr>
-              <a:t>https://kazane1225.github.io/Research_NetworkSimulater/</a:t>
+              <a:t>Legend, live stats, and an EN/JA switch.</a:t>
             </a:r>
           </a:p>
           <a:p>
@@ -4424,7 +4187,7 @@
                 <a:spcPts val="0"/>
               </a:spcBef>
               <a:spcAft>
-                <a:spcPts val="200"/>
+                <a:spcPts val="0"/>
               </a:spcAft>
             </a:pPr>
             <a:r>
@@ -4436,7 +4199,7 @@
                 <a:ea typeface="Arial"/>
                 <a:cs typeface="Arial"/>
               </a:rPr>
-              <a:t>2.3 Speed.</a:t>
+              <a:t>2.5 A worker thread can rebuild while drawing.</a:t>
             </a:r>
           </a:p>
           <a:p>
@@ -4448,7 +4211,7 @@
                 <a:spcPts val="0"/>
               </a:spcBef>
               <a:spcAft>
-                <a:spcPts val="100"/>
+                <a:spcPts val="0"/>
               </a:spcAft>
             </a:pPr>
             <a:r>
@@ -4460,7 +4223,7 @@
                 <a:ea typeface="Arial"/>
                 <a:cs typeface="Arial"/>
               </a:rPr>
-              <a:t>•  Last-round append: O(R n²) → O(n²).</a:t>
+              <a:t>GitHub Pages cannot send the headers it needs.</a:t>
             </a:r>
           </a:p>
           <a:p>
@@ -4472,7 +4235,7 @@
                 <a:spcPts val="0"/>
               </a:spcBef>
               <a:spcAft>
-                <a:spcPts val="100"/>
+                <a:spcPts val="0"/>
               </a:spcAft>
             </a:pPr>
             <a:r>
@@ -4484,7 +4247,7 @@
                 <a:ea typeface="Arial"/>
                 <a:cs typeface="Arial"/>
               </a:rPr>
-              <a:t>•  Merged tree grows by one level only.</a:t>
+              <a:t>The public demo splits that work across frames.</a:t>
             </a:r>
           </a:p>
           <a:p>
@@ -4508,185 +4271,50 @@
                 <a:ea typeface="Arial"/>
                 <a:cs typeface="Arial"/>
               </a:rPr>
-              <a:t>•  A middle edit replays only the suffix.</a:t>
-            </a:r>
-          </a:p>
-          <a:p>
-            <a:pPr algn="l">
-              <a:lnSpc>
-                <a:spcPct val="112000"/>
-              </a:lnSpc>
-              <a:spcBef>
-                <a:spcPts val="0"/>
-              </a:spcBef>
-              <a:spcAft>
-                <a:spcPts val="100"/>
-              </a:spcAft>
-            </a:pPr>
-            <a:r>
-              <a:rPr sz="1500" b="0" i="0">
-                <a:solidFill>
-                  <a:srgbClr val="222222"/>
-                </a:solidFill>
-                <a:latin typeface="Arial"/>
-                <a:ea typeface="Arial"/>
-                <a:cs typeface="Arial"/>
-              </a:rPr>
-              <a:t>•  Hash-map merge skips identical trees.</a:t>
-            </a:r>
-          </a:p>
-          <a:p>
-            <a:pPr algn="l">
-              <a:lnSpc>
-                <a:spcPct val="112000"/>
-              </a:lnSpc>
-              <a:spcBef>
-                <a:spcPts val="0"/>
-              </a:spcBef>
-              <a:spcAft>
-                <a:spcPts val="0"/>
-              </a:spcAft>
-            </a:pPr>
-            <a:r>
-              <a:rPr sz="1500" b="0" i="0">
-                <a:solidFill>
-                  <a:srgbClr val="222222"/>
-                </a:solidFill>
-                <a:latin typeface="Arial"/>
-                <a:ea typeface="Arial"/>
-                <a:cs typeface="Arial"/>
-              </a:rPr>
-              <a:t>•  Recursion crashed near 2,000 rounds;</a:t>
-            </a:r>
-          </a:p>
-          <a:p>
-            <a:pPr algn="l">
-              <a:lnSpc>
-                <a:spcPct val="112000"/>
-              </a:lnSpc>
-              <a:spcBef>
-                <a:spcPts val="0"/>
-              </a:spcBef>
-              <a:spcAft>
-                <a:spcPts val="0"/>
-              </a:spcAft>
-            </a:pPr>
-            <a:r>
-              <a:rPr sz="1500" b="0" i="0">
-                <a:solidFill>
-                  <a:srgbClr val="222222"/>
-                </a:solidFill>
-                <a:latin typeface="Arial"/>
-                <a:ea typeface="Arial"/>
-                <a:cs typeface="Arial"/>
-              </a:rPr>
-              <a:t>   that walk is now a loop.</a:t>
-            </a:r>
-          </a:p>
-        </p:txBody>
-      </p:sp>
-      <p:sp>
-        <p:nvSpPr>
-          <p:cNvPr id="17" name="Rectangle 16"/>
-          <p:cNvSpPr/>
+              <a:t>Computing… stays up until the tree is ready.</a:t>
+            </a:r>
+          </a:p>
+        </p:txBody>
+      </p:sp>
+      <p:pic>
+        <p:nvPicPr>
+          <p:cNvPr id="15" name="Picture 14" descr="glossary_crop.png"/>
+          <p:cNvPicPr>
+            <a:picLocks noChangeAspect="1"/>
+          </p:cNvPicPr>
           <p:nvPr/>
-        </p:nvSpPr>
+        </p:nvPicPr>
+        <p:blipFill>
+          <a:blip r:embed="rId2"/>
+          <a:stretch>
+            <a:fillRect/>
+          </a:stretch>
+        </p:blipFill>
         <p:spPr>
           <a:xfrm>
-            <a:off x="219456" y="8612124"/>
-            <a:ext cx="4370832" cy="1702307"/>
+            <a:off x="219456" y="7573772"/>
+            <a:ext cx="4370832" cy="2754884"/>
           </a:xfrm>
           <a:prstGeom prst="rect">
             <a:avLst/>
           </a:prstGeom>
-          <a:solidFill>
-            <a:srgbClr val="FFFFFF"/>
-          </a:solidFill>
           <a:ln w="12700">
             <a:solidFill>
               <a:srgbClr val="395E89"/>
             </a:solidFill>
           </a:ln>
-          <a:effectLst/>
         </p:spPr>
-        <p:style>
-          <a:lnRef idx="1">
-            <a:schemeClr val="accent1"/>
-          </a:lnRef>
-          <a:fillRef idx="3">
-            <a:schemeClr val="accent1"/>
-          </a:fillRef>
-          <a:effectRef idx="2">
-            <a:schemeClr val="accent1"/>
-          </a:effectRef>
-          <a:fontRef idx="minor">
-            <a:schemeClr val="lt1"/>
-          </a:fontRef>
-        </p:style>
-        <p:txBody>
-          <a:bodyPr rtlCol="0" anchor="ctr"/>
-          <a:lstStyle/>
-          <a:p>
-            <a:pPr algn="ctr"/>
-          </a:p>
-        </p:txBody>
-      </p:sp>
-      <p:sp>
-        <p:nvSpPr>
-          <p:cNvPr id="18" name="Rectangle 17"/>
-          <p:cNvSpPr/>
+      </p:pic>
+      <p:sp>
+        <p:nvSpPr>
+          <p:cNvPr id="16" name="TextBox 15"/>
+          <p:cNvSpPr txBox="1"/>
           <p:nvPr/>
         </p:nvSpPr>
         <p:spPr>
           <a:xfrm>
-            <a:off x="1572768" y="8685276"/>
-            <a:ext cx="1600200" cy="310896"/>
-          </a:xfrm>
-          <a:prstGeom prst="rect">
-            <a:avLst/>
-          </a:prstGeom>
-          <a:solidFill>
-            <a:srgbClr val="E7EEF7"/>
-          </a:solidFill>
-          <a:ln w="14604">
-            <a:solidFill>
-              <a:srgbClr val="1F497D"/>
-            </a:solidFill>
-          </a:ln>
-          <a:effectLst/>
-        </p:spPr>
-        <p:style>
-          <a:lnRef idx="1">
-            <a:schemeClr val="accent1"/>
-          </a:lnRef>
-          <a:fillRef idx="3">
-            <a:schemeClr val="accent1"/>
-          </a:fillRef>
-          <a:effectRef idx="2">
-            <a:schemeClr val="accent1"/>
-          </a:effectRef>
-          <a:fontRef idx="minor">
-            <a:schemeClr val="lt1"/>
-          </a:fontRef>
-        </p:style>
-        <p:txBody>
-          <a:bodyPr rtlCol="0" anchor="ctr"/>
-          <a:lstStyle/>
-          <a:p>
-            <a:pPr algn="ctr"/>
-          </a:p>
-        </p:txBody>
-      </p:sp>
-      <p:sp>
-        <p:nvSpPr>
-          <p:cNvPr id="19" name="TextBox 18"/>
-          <p:cNvSpPr txBox="1"/>
-          <p:nvPr/>
-        </p:nvSpPr>
-        <p:spPr>
-          <a:xfrm>
-            <a:off x="1572768" y="8685276"/>
-            <a:ext cx="1600200" cy="310896"/>
+            <a:off x="219456" y="10356088"/>
+            <a:ext cx="4370832" cy="461264"/>
           </a:xfrm>
           <a:prstGeom prst="rect">
             <a:avLst/>
@@ -4694,1009 +4322,7 @@
           <a:noFill/>
         </p:spPr>
         <p:txBody>
-          <a:bodyPr wrap="square" lIns="18288" rIns="18288" tIns="27432" bIns="18288" anchor="ctr">
-            <a:noAutofit/>
-          </a:bodyPr>
-          <a:lstStyle/>
-          <a:p>
-            <a:pPr algn="ctr">
-              <a:lnSpc>
-                <a:spcPct val="112000"/>
-              </a:lnSpc>
-              <a:spcBef>
-                <a:spcPts val="0"/>
-              </a:spcBef>
-              <a:spcAft>
-                <a:spcPts val="0"/>
-              </a:spcAft>
-            </a:pPr>
-            <a:r>
-              <a:rPr sz="1200" b="1" i="0">
-                <a:solidFill>
-                  <a:srgbClr val="000000"/>
-                </a:solidFill>
-                <a:latin typeface="Arial"/>
-                <a:ea typeface="Arial"/>
-                <a:cs typeface="Arial"/>
-              </a:rPr>
-              <a:t>r    all agents</a:t>
-            </a:r>
-          </a:p>
-        </p:txBody>
-      </p:sp>
-      <p:sp>
-        <p:nvSpPr>
-          <p:cNvPr id="20" name="Rectangle 19"/>
-          <p:cNvSpPr/>
-          <p:nvPr/>
-        </p:nvSpPr>
-        <p:spPr>
-          <a:xfrm>
-            <a:off x="365760" y="9037137"/>
-            <a:ext cx="1691640" cy="310896"/>
-          </a:xfrm>
-          <a:prstGeom prst="rect">
-            <a:avLst/>
-          </a:prstGeom>
-          <a:solidFill>
-            <a:srgbClr val="E7EEF7"/>
-          </a:solidFill>
-          <a:ln w="14604">
-            <a:solidFill>
-              <a:srgbClr val="1F497D"/>
-            </a:solidFill>
-          </a:ln>
-          <a:effectLst/>
-        </p:spPr>
-        <p:style>
-          <a:lnRef idx="1">
-            <a:schemeClr val="accent1"/>
-          </a:lnRef>
-          <a:fillRef idx="3">
-            <a:schemeClr val="accent1"/>
-          </a:fillRef>
-          <a:effectRef idx="2">
-            <a:schemeClr val="accent1"/>
-          </a:effectRef>
-          <a:fontRef idx="minor">
-            <a:schemeClr val="lt1"/>
-          </a:fontRef>
-        </p:style>
-        <p:txBody>
-          <a:bodyPr rtlCol="0" anchor="ctr"/>
-          <a:lstStyle/>
-          <a:p>
-            <a:pPr algn="ctr"/>
-          </a:p>
-        </p:txBody>
-      </p:sp>
-      <p:sp>
-        <p:nvSpPr>
-          <p:cNvPr id="21" name="TextBox 20"/>
-          <p:cNvSpPr txBox="1"/>
-          <p:nvPr/>
-        </p:nvSpPr>
-        <p:spPr>
-          <a:xfrm>
-            <a:off x="365760" y="9037137"/>
-            <a:ext cx="1691640" cy="310896"/>
-          </a:xfrm>
-          <a:prstGeom prst="rect">
-            <a:avLst/>
-          </a:prstGeom>
-          <a:noFill/>
-        </p:spPr>
-        <p:txBody>
-          <a:bodyPr wrap="square" lIns="18288" rIns="18288" tIns="27432" bIns="18288" anchor="ctr">
-            <a:noAutofit/>
-          </a:bodyPr>
-          <a:lstStyle/>
-          <a:p>
-            <a:pPr algn="ctr">
-              <a:lnSpc>
-                <a:spcPct val="112000"/>
-              </a:lnSpc>
-              <a:spcBef>
-                <a:spcPts val="0"/>
-              </a:spcBef>
-              <a:spcAft>
-                <a:spcPts val="0"/>
-              </a:spcAft>
-            </a:pPr>
-            <a:r>
-              <a:rPr sz="1200" b="1" i="0">
-                <a:solidFill>
-                  <a:srgbClr val="000000"/>
-                </a:solidFill>
-                <a:latin typeface="Arial"/>
-                <a:ea typeface="Arial"/>
-                <a:cs typeface="Arial"/>
-              </a:rPr>
-              <a:t>leader    a = 1</a:t>
-            </a:r>
-          </a:p>
-        </p:txBody>
-      </p:sp>
-      <p:sp>
-        <p:nvSpPr>
-          <p:cNvPr id="22" name="Rectangle 21"/>
-          <p:cNvSpPr/>
-          <p:nvPr/>
-        </p:nvSpPr>
-        <p:spPr>
-          <a:xfrm>
-            <a:off x="2697480" y="9037137"/>
-            <a:ext cx="1737360" cy="310896"/>
-          </a:xfrm>
-          <a:prstGeom prst="rect">
-            <a:avLst/>
-          </a:prstGeom>
-          <a:solidFill>
-            <a:srgbClr val="E7EEF7"/>
-          </a:solidFill>
-          <a:ln w="14604">
-            <a:solidFill>
-              <a:srgbClr val="1F497D"/>
-            </a:solidFill>
-          </a:ln>
-          <a:effectLst/>
-        </p:spPr>
-        <p:style>
-          <a:lnRef idx="1">
-            <a:schemeClr val="accent1"/>
-          </a:lnRef>
-          <a:fillRef idx="3">
-            <a:schemeClr val="accent1"/>
-          </a:fillRef>
-          <a:effectRef idx="2">
-            <a:schemeClr val="accent1"/>
-          </a:effectRef>
-          <a:fontRef idx="minor">
-            <a:schemeClr val="lt1"/>
-          </a:fontRef>
-        </p:style>
-        <p:txBody>
-          <a:bodyPr rtlCol="0" anchor="ctr"/>
-          <a:lstStyle/>
-          <a:p>
-            <a:pPr algn="ctr"/>
-          </a:p>
-        </p:txBody>
-      </p:sp>
-      <p:sp>
-        <p:nvSpPr>
-          <p:cNvPr id="23" name="TextBox 22"/>
-          <p:cNvSpPr txBox="1"/>
-          <p:nvPr/>
-        </p:nvSpPr>
-        <p:spPr>
-          <a:xfrm>
-            <a:off x="2697480" y="9037137"/>
-            <a:ext cx="1737360" cy="310896"/>
-          </a:xfrm>
-          <a:prstGeom prst="rect">
-            <a:avLst/>
-          </a:prstGeom>
-          <a:noFill/>
-        </p:spPr>
-        <p:txBody>
-          <a:bodyPr wrap="square" lIns="18288" rIns="18288" tIns="27432" bIns="18288" anchor="ctr">
-            <a:noAutofit/>
-          </a:bodyPr>
-          <a:lstStyle/>
-          <a:p>
-            <a:pPr algn="ctr">
-              <a:lnSpc>
-                <a:spcPct val="112000"/>
-              </a:lnSpc>
-              <a:spcBef>
-                <a:spcPts val="0"/>
-              </a:spcBef>
-              <a:spcAft>
-                <a:spcPts val="0"/>
-              </a:spcAft>
-            </a:pPr>
-            <a:r>
-              <a:rPr sz="1200" b="1" i="0">
-                <a:solidFill>
-                  <a:srgbClr val="000000"/>
-                </a:solidFill>
-                <a:latin typeface="Arial"/>
-                <a:ea typeface="Arial"/>
-                <a:cs typeface="Arial"/>
-              </a:rPr>
-              <a:t>others   a = n−1</a:t>
-            </a:r>
-          </a:p>
-        </p:txBody>
-      </p:sp>
-      <p:sp>
-        <p:nvSpPr>
-          <p:cNvPr id="24" name="Rectangle 23"/>
-          <p:cNvSpPr/>
-          <p:nvPr/>
-        </p:nvSpPr>
-        <p:spPr>
-          <a:xfrm>
-            <a:off x="566928" y="9418319"/>
-            <a:ext cx="1280160" cy="310896"/>
-          </a:xfrm>
-          <a:prstGeom prst="rect">
-            <a:avLst/>
-          </a:prstGeom>
-          <a:solidFill>
-            <a:srgbClr val="C6EFCE"/>
-          </a:solidFill>
-          <a:ln w="14604">
-            <a:solidFill>
-              <a:srgbClr val="1F497D"/>
-            </a:solidFill>
-          </a:ln>
-          <a:effectLst/>
-        </p:spPr>
-        <p:style>
-          <a:lnRef idx="1">
-            <a:schemeClr val="accent1"/>
-          </a:lnRef>
-          <a:fillRef idx="3">
-            <a:schemeClr val="accent1"/>
-          </a:fillRef>
-          <a:effectRef idx="2">
-            <a:schemeClr val="accent1"/>
-          </a:effectRef>
-          <a:fontRef idx="minor">
-            <a:schemeClr val="lt1"/>
-          </a:fontRef>
-        </p:style>
-        <p:txBody>
-          <a:bodyPr rtlCol="0" anchor="ctr"/>
-          <a:lstStyle/>
-          <a:p>
-            <a:pPr algn="ctr"/>
-          </a:p>
-        </p:txBody>
-      </p:sp>
-      <p:sp>
-        <p:nvSpPr>
-          <p:cNvPr id="25" name="TextBox 24"/>
-          <p:cNvSpPr txBox="1"/>
-          <p:nvPr/>
-        </p:nvSpPr>
-        <p:spPr>
-          <a:xfrm>
-            <a:off x="566928" y="9418319"/>
-            <a:ext cx="1280160" cy="310896"/>
-          </a:xfrm>
-          <a:prstGeom prst="rect">
-            <a:avLst/>
-          </a:prstGeom>
-          <a:noFill/>
-        </p:spPr>
-        <p:txBody>
-          <a:bodyPr wrap="square" lIns="18288" rIns="18288" tIns="27432" bIns="18288" anchor="ctr">
-            <a:noAutofit/>
-          </a:bodyPr>
-          <a:lstStyle/>
-          <a:p>
-            <a:pPr algn="ctr">
-              <a:lnSpc>
-                <a:spcPct val="112000"/>
-              </a:lnSpc>
-              <a:spcBef>
-                <a:spcPts val="0"/>
-              </a:spcBef>
-              <a:spcAft>
-                <a:spcPts val="0"/>
-              </a:spcAft>
-            </a:pPr>
-            <a:r>
-              <a:rPr sz="1200" b="1" i="0">
-                <a:solidFill>
-                  <a:srgbClr val="000000"/>
-                </a:solidFill>
-                <a:latin typeface="Arial"/>
-                <a:ea typeface="Arial"/>
-                <a:cs typeface="Arial"/>
-              </a:rPr>
-              <a:t>leader</a:t>
-            </a:r>
-          </a:p>
-        </p:txBody>
-      </p:sp>
-      <p:sp>
-        <p:nvSpPr>
-          <p:cNvPr id="26" name="Rectangle 25"/>
-          <p:cNvSpPr/>
-          <p:nvPr/>
-        </p:nvSpPr>
-        <p:spPr>
-          <a:xfrm>
-            <a:off x="2606040" y="9418319"/>
-            <a:ext cx="822960" cy="310896"/>
-          </a:xfrm>
-          <a:prstGeom prst="rect">
-            <a:avLst/>
-          </a:prstGeom>
-          <a:solidFill>
-            <a:srgbClr val="FFF2CC"/>
-          </a:solidFill>
-          <a:ln w="14604">
-            <a:solidFill>
-              <a:srgbClr val="1F497D"/>
-            </a:solidFill>
-          </a:ln>
-          <a:effectLst/>
-        </p:spPr>
-        <p:style>
-          <a:lnRef idx="1">
-            <a:schemeClr val="accent1"/>
-          </a:lnRef>
-          <a:fillRef idx="3">
-            <a:schemeClr val="accent1"/>
-          </a:fillRef>
-          <a:effectRef idx="2">
-            <a:schemeClr val="accent1"/>
-          </a:effectRef>
-          <a:fontRef idx="minor">
-            <a:schemeClr val="lt1"/>
-          </a:fontRef>
-        </p:style>
-        <p:txBody>
-          <a:bodyPr rtlCol="0" anchor="ctr"/>
-          <a:lstStyle/>
-          <a:p>
-            <a:pPr algn="ctr"/>
-          </a:p>
-        </p:txBody>
-      </p:sp>
-      <p:sp>
-        <p:nvSpPr>
-          <p:cNvPr id="27" name="TextBox 26"/>
-          <p:cNvSpPr txBox="1"/>
-          <p:nvPr/>
-        </p:nvSpPr>
-        <p:spPr>
-          <a:xfrm>
-            <a:off x="2606040" y="9418319"/>
-            <a:ext cx="822960" cy="310896"/>
-          </a:xfrm>
-          <a:prstGeom prst="rect">
-            <a:avLst/>
-          </a:prstGeom>
-          <a:noFill/>
-        </p:spPr>
-        <p:txBody>
-          <a:bodyPr wrap="square" lIns="18288" rIns="18288" tIns="27432" bIns="18288" anchor="ctr">
-            <a:noAutofit/>
-          </a:bodyPr>
-          <a:lstStyle/>
-          <a:p>
-            <a:pPr algn="ctr">
-              <a:lnSpc>
-                <a:spcPct val="112000"/>
-              </a:lnSpc>
-              <a:spcBef>
-                <a:spcPts val="0"/>
-              </a:spcBef>
-              <a:spcAft>
-                <a:spcPts val="0"/>
-              </a:spcAft>
-            </a:pPr>
-            <a:r>
-              <a:rPr sz="1200" b="1" i="0">
-                <a:solidFill>
-                  <a:srgbClr val="000000"/>
-                </a:solidFill>
-                <a:latin typeface="Arial"/>
-                <a:ea typeface="Arial"/>
-                <a:cs typeface="Arial"/>
-              </a:rPr>
-              <a:t>A</a:t>
-            </a:r>
-          </a:p>
-        </p:txBody>
-      </p:sp>
-      <p:sp>
-        <p:nvSpPr>
-          <p:cNvPr id="28" name="Rectangle 27"/>
-          <p:cNvSpPr/>
-          <p:nvPr/>
-        </p:nvSpPr>
-        <p:spPr>
-          <a:xfrm>
-            <a:off x="3566160" y="9418319"/>
-            <a:ext cx="822960" cy="310896"/>
-          </a:xfrm>
-          <a:prstGeom prst="rect">
-            <a:avLst/>
-          </a:prstGeom>
-          <a:solidFill>
-            <a:srgbClr val="FFF2CC"/>
-          </a:solidFill>
-          <a:ln w="14604">
-            <a:solidFill>
-              <a:srgbClr val="1F497D"/>
-            </a:solidFill>
-          </a:ln>
-          <a:effectLst/>
-        </p:spPr>
-        <p:style>
-          <a:lnRef idx="1">
-            <a:schemeClr val="accent1"/>
-          </a:lnRef>
-          <a:fillRef idx="3">
-            <a:schemeClr val="accent1"/>
-          </a:fillRef>
-          <a:effectRef idx="2">
-            <a:schemeClr val="accent1"/>
-          </a:effectRef>
-          <a:fontRef idx="minor">
-            <a:schemeClr val="lt1"/>
-          </a:fontRef>
-        </p:style>
-        <p:txBody>
-          <a:bodyPr rtlCol="0" anchor="ctr"/>
-          <a:lstStyle/>
-          <a:p>
-            <a:pPr algn="ctr"/>
-          </a:p>
-        </p:txBody>
-      </p:sp>
-      <p:sp>
-        <p:nvSpPr>
-          <p:cNvPr id="29" name="TextBox 28"/>
-          <p:cNvSpPr txBox="1"/>
-          <p:nvPr/>
-        </p:nvSpPr>
-        <p:spPr>
-          <a:xfrm>
-            <a:off x="3566160" y="9418319"/>
-            <a:ext cx="822960" cy="310896"/>
-          </a:xfrm>
-          <a:prstGeom prst="rect">
-            <a:avLst/>
-          </a:prstGeom>
-          <a:noFill/>
-        </p:spPr>
-        <p:txBody>
-          <a:bodyPr wrap="square" lIns="18288" rIns="18288" tIns="27432" bIns="18288" anchor="ctr">
-            <a:noAutofit/>
-          </a:bodyPr>
-          <a:lstStyle/>
-          <a:p>
-            <a:pPr algn="ctr">
-              <a:lnSpc>
-                <a:spcPct val="112000"/>
-              </a:lnSpc>
-              <a:spcBef>
-                <a:spcPts val="0"/>
-              </a:spcBef>
-              <a:spcAft>
-                <a:spcPts val="0"/>
-              </a:spcAft>
-            </a:pPr>
-            <a:r>
-              <a:rPr sz="1200" b="1" i="0">
-                <a:solidFill>
-                  <a:srgbClr val="000000"/>
-                </a:solidFill>
-                <a:latin typeface="Arial"/>
-                <a:ea typeface="Arial"/>
-                <a:cs typeface="Arial"/>
-              </a:rPr>
-              <a:t>B</a:t>
-            </a:r>
-          </a:p>
-        </p:txBody>
-      </p:sp>
-      <p:cxnSp>
-        <p:nvCxnSpPr>
-          <p:cNvPr id="30" name="Connector 29"/>
-          <p:cNvCxnSpPr/>
-          <p:nvPr/>
-        </p:nvCxnSpPr>
-        <p:spPr>
-          <a:xfrm>
-            <a:off x="2377440" y="9014460"/>
-            <a:ext cx="0" cy="2194"/>
-          </a:xfrm>
-          <a:prstGeom prst="line">
-            <a:avLst/>
-          </a:prstGeom>
-          <a:ln w="15875">
-            <a:solidFill>
-              <a:srgbClr val="000000"/>
-            </a:solidFill>
-          </a:ln>
-        </p:spPr>
-        <p:style>
-          <a:lnRef idx="2">
-            <a:schemeClr val="accent1"/>
-          </a:lnRef>
-          <a:fillRef idx="0">
-            <a:schemeClr val="accent1"/>
-          </a:fillRef>
-          <a:effectRef idx="1">
-            <a:schemeClr val="accent1"/>
-          </a:effectRef>
-          <a:fontRef idx="minor">
-            <a:schemeClr val="tx1"/>
-          </a:fontRef>
-        </p:style>
-      </p:cxnSp>
-      <p:cxnSp>
-        <p:nvCxnSpPr>
-          <p:cNvPr id="31" name="Connector 30"/>
-          <p:cNvCxnSpPr/>
-          <p:nvPr/>
-        </p:nvCxnSpPr>
-        <p:spPr>
-          <a:xfrm>
-            <a:off x="1207008" y="9016654"/>
-            <a:ext cx="1170432" cy="0"/>
-          </a:xfrm>
-          <a:prstGeom prst="line">
-            <a:avLst/>
-          </a:prstGeom>
-          <a:ln w="15875">
-            <a:solidFill>
-              <a:srgbClr val="000000"/>
-            </a:solidFill>
-          </a:ln>
-        </p:spPr>
-        <p:style>
-          <a:lnRef idx="2">
-            <a:schemeClr val="accent1"/>
-          </a:lnRef>
-          <a:fillRef idx="0">
-            <a:schemeClr val="accent1"/>
-          </a:fillRef>
-          <a:effectRef idx="1">
-            <a:schemeClr val="accent1"/>
-          </a:effectRef>
-          <a:fontRef idx="minor">
-            <a:schemeClr val="tx1"/>
-          </a:fontRef>
-        </p:style>
-      </p:cxnSp>
-      <p:cxnSp>
-        <p:nvCxnSpPr>
-          <p:cNvPr id="32" name="Connector 31"/>
-          <p:cNvCxnSpPr/>
-          <p:nvPr/>
-        </p:nvCxnSpPr>
-        <p:spPr>
-          <a:xfrm>
-            <a:off x="1207008" y="9016654"/>
-            <a:ext cx="0" cy="2195"/>
-          </a:xfrm>
-          <a:prstGeom prst="line">
-            <a:avLst/>
-          </a:prstGeom>
-          <a:ln w="15875">
-            <a:solidFill>
-              <a:srgbClr val="000000"/>
-            </a:solidFill>
-          </a:ln>
-        </p:spPr>
-        <p:style>
-          <a:lnRef idx="2">
-            <a:schemeClr val="accent1"/>
-          </a:lnRef>
-          <a:fillRef idx="0">
-            <a:schemeClr val="accent1"/>
-          </a:fillRef>
-          <a:effectRef idx="1">
-            <a:schemeClr val="accent1"/>
-          </a:effectRef>
-          <a:fontRef idx="minor">
-            <a:schemeClr val="tx1"/>
-          </a:fontRef>
-        </p:style>
-      </p:cxnSp>
-      <p:cxnSp>
-        <p:nvCxnSpPr>
-          <p:cNvPr id="33" name="Connector 32"/>
-          <p:cNvCxnSpPr/>
-          <p:nvPr/>
-        </p:nvCxnSpPr>
-        <p:spPr>
-          <a:xfrm flipH="1">
-            <a:off x="2377440" y="9016654"/>
-            <a:ext cx="1188720" cy="0"/>
-          </a:xfrm>
-          <a:prstGeom prst="line">
-            <a:avLst/>
-          </a:prstGeom>
-          <a:ln w="15875">
-            <a:solidFill>
-              <a:srgbClr val="000000"/>
-            </a:solidFill>
-          </a:ln>
-        </p:spPr>
-        <p:style>
-          <a:lnRef idx="2">
-            <a:schemeClr val="accent1"/>
-          </a:lnRef>
-          <a:fillRef idx="0">
-            <a:schemeClr val="accent1"/>
-          </a:fillRef>
-          <a:effectRef idx="1">
-            <a:schemeClr val="accent1"/>
-          </a:effectRef>
-          <a:fontRef idx="minor">
-            <a:schemeClr val="tx1"/>
-          </a:fontRef>
-        </p:style>
-      </p:cxnSp>
-      <p:cxnSp>
-        <p:nvCxnSpPr>
-          <p:cNvPr id="34" name="Connector 33"/>
-          <p:cNvCxnSpPr/>
-          <p:nvPr/>
-        </p:nvCxnSpPr>
-        <p:spPr>
-          <a:xfrm>
-            <a:off x="3566160" y="9016654"/>
-            <a:ext cx="0" cy="2195"/>
-          </a:xfrm>
-          <a:prstGeom prst="line">
-            <a:avLst/>
-          </a:prstGeom>
-          <a:ln w="15875">
-            <a:solidFill>
-              <a:srgbClr val="000000"/>
-            </a:solidFill>
-          </a:ln>
-        </p:spPr>
-        <p:style>
-          <a:lnRef idx="2">
-            <a:schemeClr val="accent1"/>
-          </a:lnRef>
-          <a:fillRef idx="0">
-            <a:schemeClr val="accent1"/>
-          </a:fillRef>
-          <a:effectRef idx="1">
-            <a:schemeClr val="accent1"/>
-          </a:effectRef>
-          <a:fontRef idx="minor">
-            <a:schemeClr val="tx1"/>
-          </a:fontRef>
-        </p:style>
-      </p:cxnSp>
-      <p:cxnSp>
-        <p:nvCxnSpPr>
-          <p:cNvPr id="35" name="Connector 34"/>
-          <p:cNvCxnSpPr/>
-          <p:nvPr/>
-        </p:nvCxnSpPr>
-        <p:spPr>
-          <a:xfrm>
-            <a:off x="1207008" y="9366321"/>
-            <a:ext cx="0" cy="33711"/>
-          </a:xfrm>
-          <a:prstGeom prst="line">
-            <a:avLst/>
-          </a:prstGeom>
-          <a:ln w="15875">
-            <a:solidFill>
-              <a:srgbClr val="000000"/>
-            </a:solidFill>
-          </a:ln>
-        </p:spPr>
-        <p:style>
-          <a:lnRef idx="2">
-            <a:schemeClr val="accent1"/>
-          </a:lnRef>
-          <a:fillRef idx="0">
-            <a:schemeClr val="accent1"/>
-          </a:fillRef>
-          <a:effectRef idx="1">
-            <a:schemeClr val="accent1"/>
-          </a:effectRef>
-          <a:fontRef idx="minor">
-            <a:schemeClr val="tx1"/>
-          </a:fontRef>
-        </p:style>
-      </p:cxnSp>
-      <p:cxnSp>
-        <p:nvCxnSpPr>
-          <p:cNvPr id="36" name="Connector 35"/>
-          <p:cNvCxnSpPr/>
-          <p:nvPr/>
-        </p:nvCxnSpPr>
-        <p:spPr>
-          <a:xfrm>
-            <a:off x="3566160" y="9366321"/>
-            <a:ext cx="0" cy="16855"/>
-          </a:xfrm>
-          <a:prstGeom prst="line">
-            <a:avLst/>
-          </a:prstGeom>
-          <a:ln w="15875">
-            <a:solidFill>
-              <a:srgbClr val="000000"/>
-            </a:solidFill>
-          </a:ln>
-        </p:spPr>
-        <p:style>
-          <a:lnRef idx="2">
-            <a:schemeClr val="accent1"/>
-          </a:lnRef>
-          <a:fillRef idx="0">
-            <a:schemeClr val="accent1"/>
-          </a:fillRef>
-          <a:effectRef idx="1">
-            <a:schemeClr val="accent1"/>
-          </a:effectRef>
-          <a:fontRef idx="minor">
-            <a:schemeClr val="tx1"/>
-          </a:fontRef>
-        </p:style>
-      </p:cxnSp>
-      <p:cxnSp>
-        <p:nvCxnSpPr>
-          <p:cNvPr id="37" name="Connector 36"/>
-          <p:cNvCxnSpPr/>
-          <p:nvPr/>
-        </p:nvCxnSpPr>
-        <p:spPr>
-          <a:xfrm>
-            <a:off x="3017520" y="9383176"/>
-            <a:ext cx="548640" cy="0"/>
-          </a:xfrm>
-          <a:prstGeom prst="line">
-            <a:avLst/>
-          </a:prstGeom>
-          <a:ln w="15875">
-            <a:solidFill>
-              <a:srgbClr val="000000"/>
-            </a:solidFill>
-          </a:ln>
-        </p:spPr>
-        <p:style>
-          <a:lnRef idx="2">
-            <a:schemeClr val="accent1"/>
-          </a:lnRef>
-          <a:fillRef idx="0">
-            <a:schemeClr val="accent1"/>
-          </a:fillRef>
-          <a:effectRef idx="1">
-            <a:schemeClr val="accent1"/>
-          </a:effectRef>
-          <a:fontRef idx="minor">
-            <a:schemeClr val="tx1"/>
-          </a:fontRef>
-        </p:style>
-      </p:cxnSp>
-      <p:cxnSp>
-        <p:nvCxnSpPr>
-          <p:cNvPr id="38" name="Connector 37"/>
-          <p:cNvCxnSpPr/>
-          <p:nvPr/>
-        </p:nvCxnSpPr>
-        <p:spPr>
-          <a:xfrm>
-            <a:off x="3017520" y="9383176"/>
-            <a:ext cx="0" cy="16856"/>
-          </a:xfrm>
-          <a:prstGeom prst="line">
-            <a:avLst/>
-          </a:prstGeom>
-          <a:ln w="15875">
-            <a:solidFill>
-              <a:srgbClr val="000000"/>
-            </a:solidFill>
-          </a:ln>
-        </p:spPr>
-        <p:style>
-          <a:lnRef idx="2">
-            <a:schemeClr val="accent1"/>
-          </a:lnRef>
-          <a:fillRef idx="0">
-            <a:schemeClr val="accent1"/>
-          </a:fillRef>
-          <a:effectRef idx="1">
-            <a:schemeClr val="accent1"/>
-          </a:effectRef>
-          <a:fontRef idx="minor">
-            <a:schemeClr val="tx1"/>
-          </a:fontRef>
-        </p:style>
-      </p:cxnSp>
-      <p:cxnSp>
-        <p:nvCxnSpPr>
-          <p:cNvPr id="39" name="Connector 38"/>
-          <p:cNvCxnSpPr/>
-          <p:nvPr/>
-        </p:nvCxnSpPr>
-        <p:spPr>
-          <a:xfrm flipH="1">
-            <a:off x="3566160" y="9383176"/>
-            <a:ext cx="411479" cy="0"/>
-          </a:xfrm>
-          <a:prstGeom prst="line">
-            <a:avLst/>
-          </a:prstGeom>
-          <a:ln w="15875">
-            <a:solidFill>
-              <a:srgbClr val="000000"/>
-            </a:solidFill>
-          </a:ln>
-        </p:spPr>
-        <p:style>
-          <a:lnRef idx="2">
-            <a:schemeClr val="accent1"/>
-          </a:lnRef>
-          <a:fillRef idx="0">
-            <a:schemeClr val="accent1"/>
-          </a:fillRef>
-          <a:effectRef idx="1">
-            <a:schemeClr val="accent1"/>
-          </a:effectRef>
-          <a:fontRef idx="minor">
-            <a:schemeClr val="tx1"/>
-          </a:fontRef>
-        </p:style>
-      </p:cxnSp>
-      <p:cxnSp>
-        <p:nvCxnSpPr>
-          <p:cNvPr id="40" name="Connector 39"/>
-          <p:cNvCxnSpPr/>
-          <p:nvPr/>
-        </p:nvCxnSpPr>
-        <p:spPr>
-          <a:xfrm>
-            <a:off x="3977639" y="9383176"/>
-            <a:ext cx="0" cy="16856"/>
-          </a:xfrm>
-          <a:prstGeom prst="line">
-            <a:avLst/>
-          </a:prstGeom>
-          <a:ln w="15875">
-            <a:solidFill>
-              <a:srgbClr val="000000"/>
-            </a:solidFill>
-          </a:ln>
-        </p:spPr>
-        <p:style>
-          <a:lnRef idx="2">
-            <a:schemeClr val="accent1"/>
-          </a:lnRef>
-          <a:fillRef idx="0">
-            <a:schemeClr val="accent1"/>
-          </a:fillRef>
-          <a:effectRef idx="1">
-            <a:schemeClr val="accent1"/>
-          </a:effectRef>
-          <a:fontRef idx="minor">
-            <a:schemeClr val="tx1"/>
-          </a:fontRef>
-        </p:style>
-      </p:cxnSp>
-      <p:cxnSp>
-        <p:nvCxnSpPr>
-          <p:cNvPr id="41" name="Connector 40"/>
-          <p:cNvCxnSpPr/>
-          <p:nvPr/>
-        </p:nvCxnSpPr>
-        <p:spPr>
-          <a:xfrm>
-            <a:off x="2057400" y="9192585"/>
-            <a:ext cx="210312" cy="0"/>
-          </a:xfrm>
-          <a:prstGeom prst="line">
-            <a:avLst/>
-          </a:prstGeom>
-          <a:ln w="22225">
-            <a:solidFill>
-              <a:srgbClr val="C0504D"/>
-            </a:solidFill>
-          </a:ln>
-        </p:spPr>
-        <p:style>
-          <a:lnRef idx="2">
-            <a:schemeClr val="accent1"/>
-          </a:lnRef>
-          <a:fillRef idx="0">
-            <a:schemeClr val="accent1"/>
-          </a:fillRef>
-          <a:effectRef idx="1">
-            <a:schemeClr val="accent1"/>
-          </a:effectRef>
-          <a:fontRef idx="minor">
-            <a:schemeClr val="tx1"/>
-          </a:fontRef>
-        </p:style>
-      </p:cxnSp>
-      <p:cxnSp>
-        <p:nvCxnSpPr>
-          <p:cNvPr id="42" name="Connector 41"/>
-          <p:cNvCxnSpPr/>
-          <p:nvPr/>
-        </p:nvCxnSpPr>
-        <p:spPr>
-          <a:xfrm>
-            <a:off x="2267712" y="9192585"/>
-            <a:ext cx="0" cy="381182"/>
-          </a:xfrm>
-          <a:prstGeom prst="line">
-            <a:avLst/>
-          </a:prstGeom>
-          <a:ln w="22225">
-            <a:solidFill>
-              <a:srgbClr val="C0504D"/>
-            </a:solidFill>
-          </a:ln>
-        </p:spPr>
-        <p:style>
-          <a:lnRef idx="2">
-            <a:schemeClr val="accent1"/>
-          </a:lnRef>
-          <a:fillRef idx="0">
-            <a:schemeClr val="accent1"/>
-          </a:fillRef>
-          <a:effectRef idx="1">
-            <a:schemeClr val="accent1"/>
-          </a:effectRef>
-          <a:fontRef idx="minor">
-            <a:schemeClr val="tx1"/>
-          </a:fontRef>
-        </p:style>
-      </p:cxnSp>
-      <p:cxnSp>
-        <p:nvCxnSpPr>
-          <p:cNvPr id="43" name="Connector 42"/>
-          <p:cNvCxnSpPr/>
-          <p:nvPr/>
-        </p:nvCxnSpPr>
-        <p:spPr>
-          <a:xfrm>
-            <a:off x="2267712" y="9573767"/>
-            <a:ext cx="219456" cy="0"/>
-          </a:xfrm>
-          <a:prstGeom prst="line">
-            <a:avLst/>
-          </a:prstGeom>
-          <a:ln w="22225">
-            <a:solidFill>
-              <a:srgbClr val="C0504D"/>
-            </a:solidFill>
-          </a:ln>
-        </p:spPr>
-        <p:style>
-          <a:lnRef idx="2">
-            <a:schemeClr val="accent1"/>
-          </a:lnRef>
-          <a:fillRef idx="0">
-            <a:schemeClr val="accent1"/>
-          </a:fillRef>
-          <a:effectRef idx="1">
-            <a:schemeClr val="accent1"/>
-          </a:effectRef>
-          <a:fontRef idx="minor">
-            <a:schemeClr val="tx1"/>
-          </a:fontRef>
-        </p:style>
-      </p:cxnSp>
-      <p:sp>
-        <p:nvSpPr>
-          <p:cNvPr id="44" name="TextBox 43"/>
-          <p:cNvSpPr txBox="1"/>
-          <p:nvPr/>
-        </p:nvSpPr>
-        <p:spPr>
-          <a:xfrm>
-            <a:off x="292608" y="9784080"/>
-            <a:ext cx="4224528" cy="493775"/>
-          </a:xfrm>
-          <a:prstGeom prst="rect">
-            <a:avLst/>
-          </a:prstGeom>
-          <a:noFill/>
-        </p:spPr>
-        <p:txBody>
-          <a:bodyPr wrap="square" lIns="18288" rIns="18288" tIns="27432" bIns="18288" anchor="t">
+          <a:bodyPr wrap="square" lIns="45720" rIns="45720" tIns="27432" bIns="18288" anchor="t">
             <a:noAutofit/>
           </a:bodyPr>
           <a:lstStyle/>
@@ -5721,14 +4347,14 @@
                 <a:ea typeface="Arial"/>
                 <a:cs typeface="Arial"/>
               </a:rPr>
-              <a:t>Fig. 2. Black edges split classes. The red edge is a message.</a:t>
-            </a:r>
-          </a:p>
-        </p:txBody>
-      </p:sp>
-      <p:sp>
-        <p:nvSpPr>
-          <p:cNvPr id="45" name="TextBox 44"/>
+              <a:t>Fig. 2. Glossary in Student mode. Left canvas: the network. Right canvas: the history tree.</a:t>
+            </a:r>
+          </a:p>
+        </p:txBody>
+      </p:sp>
+      <p:sp>
+        <p:nvSpPr>
+          <p:cNvPr id="17" name="TextBox 16"/>
           <p:cNvSpPr txBox="1"/>
           <p:nvPr/>
         </p:nvSpPr>
@@ -5775,7 +4401,7 @@
       </p:sp>
       <p:cxnSp>
         <p:nvCxnSpPr>
-          <p:cNvPr id="46" name="Connector 45"/>
+          <p:cNvPr id="18" name="Connector 17"/>
           <p:cNvCxnSpPr/>
           <p:nvPr/>
         </p:nvCxnSpPr>
@@ -5810,14 +4436,14 @@
       </p:cxnSp>
       <p:sp>
         <p:nvSpPr>
-          <p:cNvPr id="47" name="TextBox 46"/>
+          <p:cNvPr id="19" name="TextBox 18"/>
           <p:cNvSpPr txBox="1"/>
           <p:nvPr/>
         </p:nvSpPr>
         <p:spPr>
           <a:xfrm>
             <a:off x="4937760" y="1837943"/>
-            <a:ext cx="4462272" cy="2094992"/>
+            <a:ext cx="4462272" cy="2125980"/>
           </a:xfrm>
           <a:prstGeom prst="rect">
             <a:avLst/>
@@ -6030,7 +4656,7 @@
                 <a:spcPts val="0"/>
               </a:spcBef>
               <a:spcAft>
-                <a:spcPts val="0"/>
+                <a:spcPts val="100"/>
               </a:spcAft>
             </a:pPr>
             <a:r>
@@ -6049,32 +4675,32 @@
       </p:sp>
       <p:graphicFrame>
         <p:nvGraphicFramePr>
-          <p:cNvPr id="48" name="Chart 47"/>
+          <p:cNvPr id="20" name="Chart 19"/>
           <p:cNvGraphicFramePr>
             <a:graphicFrameLocks noGrp="1"/>
           </p:cNvGraphicFramePr>
           <p:nvPr/>
         </p:nvGraphicFramePr>
         <p:xfrm>
-          <a:off x="4937760" y="3969512"/>
-          <a:ext cx="4462272" cy="1261872"/>
+          <a:off x="4937760" y="4000500"/>
+          <a:ext cx="4462272" cy="1554480"/>
         </p:xfrm>
         <a:graphic>
           <a:graphicData uri="http://schemas.openxmlformats.org/drawingml/2006/chart">
-            <c:chart xmlns:c="http://schemas.openxmlformats.org/drawingml/2006/chart" r:id="rId2"/>
+            <c:chart xmlns:c="http://schemas.openxmlformats.org/drawingml/2006/chart" r:id="rId3"/>
           </a:graphicData>
         </a:graphic>
       </p:graphicFrame>
       <p:sp>
         <p:nvSpPr>
-          <p:cNvPr id="49" name="TextBox 48"/>
+          <p:cNvPr id="21" name="TextBox 20"/>
           <p:cNvSpPr txBox="1"/>
           <p:nvPr/>
         </p:nvSpPr>
         <p:spPr>
           <a:xfrm>
-            <a:off x="4937760" y="5258816"/>
-            <a:ext cx="4462272" cy="442976"/>
+            <a:off x="4937760" y="5573268"/>
+            <a:ext cx="4462272" cy="461264"/>
           </a:xfrm>
           <a:prstGeom prst="rect">
             <a:avLst/>
@@ -6114,14 +4740,14 @@
       </p:sp>
       <p:graphicFrame>
         <p:nvGraphicFramePr>
-          <p:cNvPr id="50" name="Table 49"/>
+          <p:cNvPr id="22" name="Table 21"/>
           <p:cNvGraphicFramePr>
             <a:graphicFrameLocks noGrp="1"/>
           </p:cNvGraphicFramePr>
           <p:nvPr/>
         </p:nvGraphicFramePr>
         <p:xfrm>
-          <a:off x="4937760" y="5756656"/>
+          <a:off x="4937760" y="6080252"/>
           <a:ext cx="4462272" cy="1298445"/>
         </p:xfrm>
         <a:graphic>
@@ -6131,14 +4757,14 @@
                 <a:tableStyleId>{5C22544A-7EE6-4342-B048-85BDC9FD1C3A}</a:tableStyleId>
               </a:tblPr>
               <a:tblGrid>
-                <a:gridCol w="1325880"/>
-                <a:gridCol w="1554480"/>
-                <a:gridCol w="1581912"/>
+                <a:gridCol w="1417320"/>
+                <a:gridCol w="1517904"/>
+                <a:gridCol w="1527048"/>
               </a:tblGrid>
               <a:tr h="259689">
                 <a:tc>
                   <a:txBody>
-                    <a:bodyPr wrap="square" lIns="45720" rIns="45720" tIns="18288" bIns="18288"/>
+                    <a:bodyPr wrap="square" lIns="36576" rIns="36576" tIns="18288" bIns="18288"/>
                     <a:lstStyle/>
                     <a:p>
                       <a:pPr algn="ctr">
@@ -6187,7 +4813,7 @@
                 </a:tc>
                 <a:tc>
                   <a:txBody>
-                    <a:bodyPr wrap="square" lIns="45720" rIns="45720" tIns="18288" bIns="18288"/>
+                    <a:bodyPr wrap="square" lIns="36576" rIns="36576" tIns="18288" bIns="18288"/>
                     <a:lstStyle/>
                     <a:p>
                       <a:pPr algn="ctr">
@@ -6236,7 +4862,7 @@
                 </a:tc>
                 <a:tc>
                   <a:txBody>
-                    <a:bodyPr wrap="square" lIns="45720" rIns="45720" tIns="18288" bIns="18288"/>
+                    <a:bodyPr wrap="square" lIns="36576" rIns="36576" tIns="18288" bIns="18288"/>
                     <a:lstStyle/>
                     <a:p>
                       <a:pPr algn="ctr">
@@ -6287,7 +4913,7 @@
               <a:tr h="259689">
                 <a:tc>
                   <a:txBody>
-                    <a:bodyPr wrap="square" lIns="45720" rIns="45720" tIns="18288" bIns="18288"/>
+                    <a:bodyPr wrap="square" lIns="36576" rIns="36576" tIns="18288" bIns="18288"/>
                     <a:lstStyle/>
                     <a:p>
                       <a:pPr algn="l">
@@ -6336,7 +4962,7 @@
                 </a:tc>
                 <a:tc>
                   <a:txBody>
-                    <a:bodyPr wrap="square" lIns="45720" rIns="45720" tIns="18288" bIns="18288"/>
+                    <a:bodyPr wrap="square" lIns="36576" rIns="36576" tIns="18288" bIns="18288"/>
                     <a:lstStyle/>
                     <a:p>
                       <a:pPr algn="ctr">
@@ -6385,7 +5011,7 @@
                 </a:tc>
                 <a:tc>
                   <a:txBody>
-                    <a:bodyPr wrap="square" lIns="45720" rIns="45720" tIns="18288" bIns="18288"/>
+                    <a:bodyPr wrap="square" lIns="36576" rIns="36576" tIns="18288" bIns="18288"/>
                     <a:lstStyle/>
                     <a:p>
                       <a:pPr algn="ctr">
@@ -6436,7 +5062,7 @@
               <a:tr h="259689">
                 <a:tc>
                   <a:txBody>
-                    <a:bodyPr wrap="square" lIns="45720" rIns="45720" tIns="18288" bIns="18288"/>
+                    <a:bodyPr wrap="square" lIns="36576" rIns="36576" tIns="18288" bIns="18288"/>
                     <a:lstStyle/>
                     <a:p>
                       <a:pPr algn="l">
@@ -6485,7 +5111,7 @@
                 </a:tc>
                 <a:tc>
                   <a:txBody>
-                    <a:bodyPr wrap="square" lIns="45720" rIns="45720" tIns="18288" bIns="18288"/>
+                    <a:bodyPr wrap="square" lIns="36576" rIns="36576" tIns="18288" bIns="18288"/>
                     <a:lstStyle/>
                     <a:p>
                       <a:pPr algn="ctr">
@@ -6534,7 +5160,7 @@
                 </a:tc>
                 <a:tc>
                   <a:txBody>
-                    <a:bodyPr wrap="square" lIns="45720" rIns="45720" tIns="18288" bIns="18288"/>
+                    <a:bodyPr wrap="square" lIns="36576" rIns="36576" tIns="18288" bIns="18288"/>
                     <a:lstStyle/>
                     <a:p>
                       <a:pPr algn="ctr">
@@ -6585,7 +5211,7 @@
               <a:tr h="259689">
                 <a:tc>
                   <a:txBody>
-                    <a:bodyPr wrap="square" lIns="45720" rIns="45720" tIns="18288" bIns="18288"/>
+                    <a:bodyPr wrap="square" lIns="36576" rIns="36576" tIns="18288" bIns="18288"/>
                     <a:lstStyle/>
                     <a:p>
                       <a:pPr algn="l">
@@ -6634,7 +5260,7 @@
                 </a:tc>
                 <a:tc>
                   <a:txBody>
-                    <a:bodyPr wrap="square" lIns="45720" rIns="45720" tIns="18288" bIns="18288"/>
+                    <a:bodyPr wrap="square" lIns="36576" rIns="36576" tIns="18288" bIns="18288"/>
                     <a:lstStyle/>
                     <a:p>
                       <a:pPr algn="ctr">
@@ -6683,7 +5309,7 @@
                 </a:tc>
                 <a:tc>
                   <a:txBody>
-                    <a:bodyPr wrap="square" lIns="45720" rIns="45720" tIns="18288" bIns="18288"/>
+                    <a:bodyPr wrap="square" lIns="36576" rIns="36576" tIns="18288" bIns="18288"/>
                     <a:lstStyle/>
                     <a:p>
                       <a:pPr algn="ctr">
@@ -6734,7 +5360,7 @@
               <a:tr h="259689">
                 <a:tc>
                   <a:txBody>
-                    <a:bodyPr wrap="square" lIns="45720" rIns="45720" tIns="18288" bIns="18288"/>
+                    <a:bodyPr wrap="square" lIns="36576" rIns="36576" tIns="18288" bIns="18288"/>
                     <a:lstStyle/>
                     <a:p>
                       <a:pPr algn="l">
@@ -6783,7 +5409,7 @@
                 </a:tc>
                 <a:tc>
                   <a:txBody>
-                    <a:bodyPr wrap="square" lIns="45720" rIns="45720" tIns="18288" bIns="18288"/>
+                    <a:bodyPr wrap="square" lIns="36576" rIns="36576" tIns="18288" bIns="18288"/>
                     <a:lstStyle/>
                     <a:p>
                       <a:pPr algn="ctr">
@@ -6832,7 +5458,7 @@
                 </a:tc>
                 <a:tc>
                   <a:txBody>
-                    <a:bodyPr wrap="square" lIns="45720" rIns="45720" tIns="18288" bIns="18288"/>
+                    <a:bodyPr wrap="square" lIns="36576" rIns="36576" tIns="18288" bIns="18288"/>
                     <a:lstStyle/>
                     <a:p>
                       <a:pPr algn="ctr">
@@ -6886,14 +5512,14 @@
       </p:graphicFrame>
       <p:sp>
         <p:nvSpPr>
-          <p:cNvPr id="51" name="TextBox 50"/>
+          <p:cNvPr id="23" name="TextBox 22"/>
           <p:cNvSpPr txBox="1"/>
           <p:nvPr/>
         </p:nvSpPr>
         <p:spPr>
           <a:xfrm>
-            <a:off x="4937760" y="7082536"/>
-            <a:ext cx="4462272" cy="258064"/>
+            <a:off x="4937760" y="7406132"/>
+            <a:ext cx="4462272" cy="276352"/>
           </a:xfrm>
           <a:prstGeom prst="rect">
             <a:avLst/>
@@ -6933,13 +5559,13 @@
       </p:sp>
       <p:sp>
         <p:nvSpPr>
-          <p:cNvPr id="52" name="TextBox 51"/>
+          <p:cNvPr id="24" name="TextBox 23"/>
           <p:cNvSpPr txBox="1"/>
           <p:nvPr/>
         </p:nvSpPr>
         <p:spPr>
           <a:xfrm>
-            <a:off x="4937760" y="7395464"/>
+            <a:off x="4937760" y="7737347"/>
             <a:ext cx="4462272" cy="292608"/>
           </a:xfrm>
           <a:prstGeom prst="rect">
@@ -6980,13 +5606,13 @@
       </p:sp>
       <p:cxnSp>
         <p:nvCxnSpPr>
-          <p:cNvPr id="53" name="Connector 52"/>
+          <p:cNvPr id="25" name="Connector 24"/>
           <p:cNvCxnSpPr/>
           <p:nvPr/>
         </p:nvCxnSpPr>
         <p:spPr>
           <a:xfrm>
-            <a:off x="4937760" y="7688072"/>
+            <a:off x="4937760" y="8029956"/>
             <a:ext cx="4462272" cy="0"/>
           </a:xfrm>
           <a:prstGeom prst="line">
@@ -7015,14 +5641,14 @@
       </p:cxnSp>
       <p:sp>
         <p:nvSpPr>
-          <p:cNvPr id="54" name="TextBox 53"/>
+          <p:cNvPr id="26" name="TextBox 25"/>
           <p:cNvSpPr txBox="1"/>
           <p:nvPr/>
         </p:nvSpPr>
         <p:spPr>
           <a:xfrm>
-            <a:off x="4937760" y="7733792"/>
-            <a:ext cx="4462272" cy="1190752"/>
+            <a:off x="4937760" y="8075675"/>
+            <a:ext cx="4462272" cy="1447800"/>
           </a:xfrm>
           <a:prstGeom prst="rect">
             <a:avLst/>
@@ -7103,7 +5729,7 @@
                 <a:ea typeface="Arial"/>
                 <a:cs typeface="Arial"/>
               </a:rPr>
-              <a:t>•  Explain colors and red edges on the page.</a:t>
+              <a:t>•  Public page has no worker thread.</a:t>
             </a:r>
           </a:p>
           <a:p>
@@ -7127,7 +5753,7 @@
                 <a:ea typeface="Arial"/>
                 <a:cs typeface="Arial"/>
               </a:rPr>
-              <a:t>•  Later: more leaders, directed links [2].</a:t>
+              <a:t>•  Last-round edits stay on the main thread.</a:t>
             </a:r>
           </a:p>
           <a:p>
@@ -7139,7 +5765,7 @@
                 <a:spcPts val="0"/>
               </a:spcBef>
               <a:spcAft>
-                <a:spcPts val="0"/>
+                <a:spcPts val="100"/>
               </a:spcAft>
             </a:pPr>
             <a:r>
@@ -7151,21 +5777,45 @@
                 <a:ea typeface="Arial"/>
                 <a:cs typeface="Arial"/>
               </a:rPr>
-              <a:t>•  Fallback: keep fast append, state the limit.</a:t>
-            </a:r>
-          </a:p>
-        </p:txBody>
-      </p:sp>
-      <p:sp>
-        <p:nvSpPr>
-          <p:cNvPr id="55" name="Rectangle 54"/>
+              <a:t>•  Later: more leaders, directed links [2].</a:t>
+            </a:r>
+          </a:p>
+          <a:p>
+            <a:pPr algn="l">
+              <a:lnSpc>
+                <a:spcPct val="112000"/>
+              </a:lnSpc>
+              <a:spcBef>
+                <a:spcPts val="0"/>
+              </a:spcBef>
+              <a:spcAft>
+                <a:spcPts val="100"/>
+              </a:spcAft>
+            </a:pPr>
+            <a:r>
+              <a:rPr sz="1500" b="0" i="0">
+                <a:solidFill>
+                  <a:srgbClr val="222222"/>
+                </a:solidFill>
+                <a:latin typeface="Arial"/>
+                <a:ea typeface="Arial"/>
+                <a:cs typeface="Arial"/>
+              </a:rPr>
+              <a:t>•  Fallback: keep the fast last-round edit.</a:t>
+            </a:r>
+          </a:p>
+        </p:txBody>
+      </p:sp>
+      <p:sp>
+        <p:nvSpPr>
+          <p:cNvPr id="27" name="Rectangle 26"/>
           <p:cNvSpPr/>
           <p:nvPr/>
         </p:nvSpPr>
         <p:spPr>
           <a:xfrm>
-            <a:off x="4937760" y="8961120"/>
-            <a:ext cx="4462272" cy="1353311"/>
+            <a:off x="4937760" y="9569195"/>
+            <a:ext cx="4462272" cy="1239012"/>
           </a:xfrm>
           <a:prstGeom prst="rect">
             <a:avLst/>
@@ -7204,14 +5854,14 @@
       </p:sp>
       <p:sp>
         <p:nvSpPr>
-          <p:cNvPr id="56" name="TextBox 55"/>
+          <p:cNvPr id="28" name="TextBox 27"/>
           <p:cNvSpPr txBox="1"/>
           <p:nvPr/>
         </p:nvSpPr>
         <p:spPr>
           <a:xfrm>
-            <a:off x="4992624" y="8997696"/>
-            <a:ext cx="4352544" cy="1116076"/>
+            <a:off x="4992624" y="9605771"/>
+            <a:ext cx="4352544" cy="1079500"/>
           </a:xfrm>
           <a:prstGeom prst="rect">
             <a:avLst/>
@@ -7316,7 +5966,7 @@
                 <a:ea typeface="Arial"/>
                 <a:cs typeface="Arial"/>
               </a:rPr>
-              <a:t>•  Dec — explanations on the page</a:t>
+              <a:t>•  Dec — thesis text on the UI and threads</a:t>
             </a:r>
           </a:p>
           <a:p>
@@ -7347,13 +5997,13 @@
       </p:sp>
       <p:cxnSp>
         <p:nvCxnSpPr>
-          <p:cNvPr id="57" name="Connector 56"/>
+          <p:cNvPr id="29" name="Connector 28"/>
           <p:cNvCxnSpPr/>
           <p:nvPr/>
         </p:nvCxnSpPr>
         <p:spPr>
           <a:xfrm>
-            <a:off x="219456" y="10442448"/>
+            <a:off x="219456" y="10936224"/>
             <a:ext cx="9162288" cy="0"/>
           </a:xfrm>
           <a:prstGeom prst="line">
@@ -7382,14 +6032,14 @@
       </p:cxnSp>
       <p:sp>
         <p:nvSpPr>
-          <p:cNvPr id="58" name="TextBox 57"/>
+          <p:cNvPr id="30" name="TextBox 29"/>
           <p:cNvSpPr txBox="1"/>
           <p:nvPr/>
         </p:nvSpPr>
         <p:spPr>
           <a:xfrm>
-            <a:off x="219456" y="10497312"/>
-            <a:ext cx="9162288" cy="310896"/>
+            <a:off x="219456" y="10991088"/>
+            <a:ext cx="9162288" cy="292608"/>
           </a:xfrm>
           <a:prstGeom prst="rect">
             <a:avLst/>
@@ -7429,14 +6079,14 @@
       </p:sp>
       <p:sp>
         <p:nvSpPr>
-          <p:cNvPr id="59" name="TextBox 58"/>
+          <p:cNvPr id="31" name="TextBox 30"/>
           <p:cNvSpPr txBox="1"/>
           <p:nvPr/>
         </p:nvSpPr>
         <p:spPr>
           <a:xfrm>
-            <a:off x="219456" y="10826496"/>
-            <a:ext cx="9162288" cy="1420368"/>
+            <a:off x="219456" y="11301984"/>
+            <a:ext cx="9162288" cy="1400556"/>
           </a:xfrm>
           <a:prstGeom prst="rect">
             <a:avLst/>
@@ -7457,7 +6107,7 @@
                 <a:spcPts val="0"/>
               </a:spcBef>
               <a:spcAft>
-                <a:spcPts val="400"/>
+                <a:spcPts val="300"/>
               </a:spcAft>
             </a:pPr>
             <a:r>
@@ -7481,7 +6131,7 @@
                 <a:spcPts val="0"/>
               </a:spcBef>
               <a:spcAft>
-                <a:spcPts val="400"/>
+                <a:spcPts val="300"/>
               </a:spcAft>
             </a:pPr>
             <a:r>
@@ -7505,7 +6155,7 @@
                 <a:spcPts val="0"/>
               </a:spcBef>
               <a:spcAft>
-                <a:spcPts val="400"/>
+                <a:spcPts val="300"/>
               </a:spcAft>
             </a:pPr>
             <a:r>

</xml_diff>